<commit_message>
Updated answer keys and scoring script
</commit_message>
<xml_diff>
--- a/Day1/aptitude/aptitude_quiz.pptx
+++ b/Day1/aptitude/aptitude_quiz.pptx
@@ -8454,7 +8454,7 @@
           <p:spPr>
             <a:xfrm>
               <a:off x="1714500" y="1238250"/>
-              <a:ext cx="571500" cy="381000"/>
+              <a:ext cx="652780" cy="381000"/>
             </a:xfrm>
             <a:prstGeom prst="rect">
               <a:avLst/>
@@ -8489,7 +8489,31 @@
                   <a:cs typeface="Inter" panose="02000503000000020004"/>
                   <a:sym typeface="Inter" panose="02000503000000020004"/>
                 </a:rPr>
-                <a:t>BOTH (10)</a:t>
+                <a:t>BOTH (</a:t>
+              </a:r>
+              <a:r>
+                <a:rPr lang="en-US" altLang="en-GB" sz="900" b="1">
+                  <a:solidFill>
+                    <a:srgbClr val="0A192F"/>
+                  </a:solidFill>
+                  <a:latin typeface="Inter" panose="02000503000000020004"/>
+                  <a:ea typeface="Inter" panose="02000503000000020004"/>
+                  <a:cs typeface="Inter" panose="02000503000000020004"/>
+                  <a:sym typeface="Inter" panose="02000503000000020004"/>
+                </a:rPr>
+                <a:t>2</a:t>
+              </a:r>
+              <a:r>
+                <a:rPr lang="en-GB" sz="900" b="1">
+                  <a:solidFill>
+                    <a:srgbClr val="0A192F"/>
+                  </a:solidFill>
+                  <a:latin typeface="Inter" panose="02000503000000020004"/>
+                  <a:ea typeface="Inter" panose="02000503000000020004"/>
+                  <a:cs typeface="Inter" panose="02000503000000020004"/>
+                  <a:sym typeface="Inter" panose="02000503000000020004"/>
+                </a:rPr>
+                <a:t>0)</a:t>
               </a:r>
               <a:endParaRPr sz="900" b="1">
                 <a:solidFill>
@@ -8588,7 +8612,31 @@
                   <a:cs typeface="Inter SemiBold" panose="02000503000000020004"/>
                   <a:sym typeface="Inter SemiBold" panose="02000503000000020004"/>
                 </a:rPr>
-                <a:t>Total Students: 60 | Neither: 10</a:t>
+                <a:t>Total Students: </a:t>
+              </a:r>
+              <a:r>
+                <a:rPr lang="en-US" altLang="en-GB" sz="1200" b="0">
+                  <a:solidFill>
+                    <a:srgbClr val="4F5D75"/>
+                  </a:solidFill>
+                  <a:latin typeface="Inter SemiBold" panose="02000503000000020004"/>
+                  <a:ea typeface="Inter SemiBold" panose="02000503000000020004"/>
+                  <a:cs typeface="Inter SemiBold" panose="02000503000000020004"/>
+                  <a:sym typeface="Inter SemiBold" panose="02000503000000020004"/>
+                </a:rPr>
+                <a:t>5</a:t>
+              </a:r>
+              <a:r>
+                <a:rPr lang="en-GB" sz="1200" b="0">
+                  <a:solidFill>
+                    <a:srgbClr val="4F5D75"/>
+                  </a:solidFill>
+                  <a:latin typeface="Inter SemiBold" panose="02000503000000020004"/>
+                  <a:ea typeface="Inter SemiBold" panose="02000503000000020004"/>
+                  <a:cs typeface="Inter SemiBold" panose="02000503000000020004"/>
+                  <a:sym typeface="Inter SemiBold" panose="02000503000000020004"/>
+                </a:rPr>
+                <a:t>0 | Neither: 10</a:t>
               </a:r>
               <a:endParaRPr sz="1200" b="0">
                 <a:solidFill>
@@ -11505,7 +11553,7 @@
           <p:spPr>
             <a:xfrm>
               <a:off x="152400" y="381000"/>
-              <a:ext cx="3695700" cy="666900"/>
+              <a:ext cx="3695700" cy="571500"/>
             </a:xfrm>
             <a:prstGeom prst="rect">
               <a:avLst/>
@@ -11562,8 +11610,8 @@
           </p:nvSpPr>
           <p:spPr>
             <a:xfrm>
-              <a:off x="0" y="1295400"/>
-              <a:ext cx="4000500" cy="1371600"/>
+              <a:off x="0" y="1142365"/>
+              <a:ext cx="4000500" cy="1524635"/>
             </a:xfrm>
             <a:prstGeom prst="roundRect">
               <a:avLst>
@@ -11703,7 +11751,139 @@
                   <a:cs typeface="Inter" panose="02000503000000020004"/>
                   <a:sym typeface="Inter" panose="02000503000000020004"/>
                 </a:rPr>
-                <a:t>1. Absolute Decrease: 150 - 120 = ₹30</a:t>
+                <a:t>1. </a:t>
+              </a:r>
+              <a:r>
+                <a:rPr lang="en-US" altLang="en-GB" sz="1110" b="0">
+                  <a:solidFill>
+                    <a:srgbClr val="4F5D75"/>
+                  </a:solidFill>
+                  <a:latin typeface="Inter" panose="02000503000000020004"/>
+                  <a:ea typeface="Inter" panose="02000503000000020004"/>
+                  <a:cs typeface="Inter" panose="02000503000000020004"/>
+                  <a:sym typeface="Inter" panose="02000503000000020004"/>
+                </a:rPr>
+                <a:t>Change</a:t>
+              </a:r>
+              <a:r>
+                <a:rPr lang="en-GB" sz="1110" b="0">
+                  <a:solidFill>
+                    <a:srgbClr val="4F5D75"/>
+                  </a:solidFill>
+                  <a:latin typeface="Inter" panose="02000503000000020004"/>
+                  <a:ea typeface="Inter" panose="02000503000000020004"/>
+                  <a:cs typeface="Inter" panose="02000503000000020004"/>
+                  <a:sym typeface="Inter" panose="02000503000000020004"/>
+                </a:rPr>
+                <a:t>: </a:t>
+              </a:r>
+              <a:r>
+                <a:rPr lang="en-US" altLang="en-GB" sz="1110" b="0">
+                  <a:solidFill>
+                    <a:srgbClr val="4F5D75"/>
+                  </a:solidFill>
+                  <a:latin typeface="Inter" panose="02000503000000020004"/>
+                  <a:ea typeface="Inter" panose="02000503000000020004"/>
+                  <a:cs typeface="Inter" panose="02000503000000020004"/>
+                  <a:sym typeface="Inter" panose="02000503000000020004"/>
+                </a:rPr>
+                <a:t>New - Original = </a:t>
+              </a:r>
+              <a:r>
+                <a:rPr lang="en-GB" sz="1110" b="0">
+                  <a:solidFill>
+                    <a:srgbClr val="4F5D75"/>
+                  </a:solidFill>
+                  <a:latin typeface="Inter" panose="02000503000000020004"/>
+                  <a:ea typeface="Inter" panose="02000503000000020004"/>
+                  <a:cs typeface="Inter" panose="02000503000000020004"/>
+                  <a:sym typeface="Inter" panose="02000503000000020004"/>
+                </a:rPr>
+                <a:t>1</a:t>
+              </a:r>
+              <a:r>
+                <a:rPr lang="en-US" altLang="en-GB" sz="1110" b="0">
+                  <a:solidFill>
+                    <a:srgbClr val="4F5D75"/>
+                  </a:solidFill>
+                  <a:latin typeface="Inter" panose="02000503000000020004"/>
+                  <a:ea typeface="Inter" panose="02000503000000020004"/>
+                  <a:cs typeface="Inter" panose="02000503000000020004"/>
+                  <a:sym typeface="Inter" panose="02000503000000020004"/>
+                </a:rPr>
+                <a:t>20</a:t>
+              </a:r>
+              <a:r>
+                <a:rPr lang="en-GB" sz="1110" b="0">
+                  <a:solidFill>
+                    <a:srgbClr val="4F5D75"/>
+                  </a:solidFill>
+                  <a:latin typeface="Inter" panose="02000503000000020004"/>
+                  <a:ea typeface="Inter" panose="02000503000000020004"/>
+                  <a:cs typeface="Inter" panose="02000503000000020004"/>
+                  <a:sym typeface="Inter" panose="02000503000000020004"/>
+                </a:rPr>
+                <a:t> - 1</a:t>
+              </a:r>
+              <a:r>
+                <a:rPr lang="en-US" altLang="en-GB" sz="1110" b="0">
+                  <a:solidFill>
+                    <a:srgbClr val="4F5D75"/>
+                  </a:solidFill>
+                  <a:latin typeface="Inter" panose="02000503000000020004"/>
+                  <a:ea typeface="Inter" panose="02000503000000020004"/>
+                  <a:cs typeface="Inter" panose="02000503000000020004"/>
+                  <a:sym typeface="Inter" panose="02000503000000020004"/>
+                </a:rPr>
+                <a:t>5</a:t>
+              </a:r>
+              <a:r>
+                <a:rPr lang="en-GB" sz="1110" b="0">
+                  <a:solidFill>
+                    <a:srgbClr val="4F5D75"/>
+                  </a:solidFill>
+                  <a:latin typeface="Inter" panose="02000503000000020004"/>
+                  <a:ea typeface="Inter" panose="02000503000000020004"/>
+                  <a:cs typeface="Inter" panose="02000503000000020004"/>
+                  <a:sym typeface="Inter" panose="02000503000000020004"/>
+                </a:rPr>
+                <a:t>0 = </a:t>
+              </a:r>
+              <a:r>
+                <a:rPr lang="en-US" altLang="en-GB" sz="1110" b="0">
+                  <a:solidFill>
+                    <a:srgbClr val="4F5D75"/>
+                  </a:solidFill>
+                  <a:latin typeface="Inter" panose="02000503000000020004"/>
+                  <a:ea typeface="Inter" panose="02000503000000020004"/>
+                  <a:cs typeface="Inter" panose="02000503000000020004"/>
+                  <a:sym typeface="Inter" panose="02000503000000020004"/>
+                </a:rPr>
+                <a:t>- </a:t>
+              </a:r>
+              <a:r>
+                <a:rPr lang="en-GB" sz="1110" b="0">
+                  <a:solidFill>
+                    <a:srgbClr val="4F5D75"/>
+                  </a:solidFill>
+                  <a:latin typeface="Inter" panose="02000503000000020004"/>
+                  <a:ea typeface="Inter" panose="02000503000000020004"/>
+                  <a:cs typeface="Inter" panose="02000503000000020004"/>
+                  <a:sym typeface="Inter" panose="02000503000000020004"/>
+                </a:rPr>
+                <a:t>₹3</a:t>
+              </a:r>
+              <a:r>
+                <a:rPr lang="en-US" altLang="en-GB" sz="1110" b="0">
+                  <a:solidFill>
+                    <a:srgbClr val="4F5D75"/>
+                  </a:solidFill>
+                  <a:latin typeface="Inter" panose="02000503000000020004"/>
+                  <a:ea typeface="Inter" panose="02000503000000020004"/>
+                  <a:cs typeface="Inter" panose="02000503000000020004"/>
+                  <a:sym typeface="Inter" panose="02000503000000020004"/>
+                </a:rPr>
+                <a:t>0</a:t>
               </a:r>
               <a:endParaRPr sz="1110" b="0">
                 <a:solidFill>
@@ -11767,7 +11947,67 @@
                   <a:cs typeface="Inter" panose="02000503000000020004"/>
                   <a:sym typeface="Inter" panose="02000503000000020004"/>
                 </a:rPr>
-                <a:t>3. Calc: (30 / 150) × 100 = 1/5 × 100</a:t>
+                <a:t>3. Calc: (</a:t>
+              </a:r>
+              <a:r>
+                <a:rPr lang="en-US" altLang="en-GB" sz="1110" b="0">
+                  <a:solidFill>
+                    <a:srgbClr val="4F5D75"/>
+                  </a:solidFill>
+                  <a:latin typeface="Inter" panose="02000503000000020004"/>
+                  <a:ea typeface="Inter" panose="02000503000000020004"/>
+                  <a:cs typeface="Inter" panose="02000503000000020004"/>
+                  <a:sym typeface="Inter" panose="02000503000000020004"/>
+                </a:rPr>
+                <a:t>-</a:t>
+              </a:r>
+              <a:r>
+                <a:rPr lang="en-GB" sz="1110" b="0">
+                  <a:solidFill>
+                    <a:srgbClr val="4F5D75"/>
+                  </a:solidFill>
+                  <a:latin typeface="Inter" panose="02000503000000020004"/>
+                  <a:ea typeface="Inter" panose="02000503000000020004"/>
+                  <a:cs typeface="Inter" panose="02000503000000020004"/>
+                  <a:sym typeface="Inter" panose="02000503000000020004"/>
+                </a:rPr>
+                <a:t>30 / 150) × 100 = </a:t>
+              </a:r>
+              <a:r>
+                <a:rPr lang="en-US" altLang="en-GB" sz="1110" b="0">
+                  <a:solidFill>
+                    <a:srgbClr val="4F5D75"/>
+                  </a:solidFill>
+                  <a:latin typeface="Inter" panose="02000503000000020004"/>
+                  <a:ea typeface="Inter" panose="02000503000000020004"/>
+                  <a:cs typeface="Inter" panose="02000503000000020004"/>
+                  <a:sym typeface="Inter" panose="02000503000000020004"/>
+                </a:rPr>
+                <a:t>-</a:t>
+              </a:r>
+              <a:r>
+                <a:rPr lang="en-GB" sz="1110" b="0">
+                  <a:solidFill>
+                    <a:srgbClr val="4F5D75"/>
+                  </a:solidFill>
+                  <a:latin typeface="Inter" panose="02000503000000020004"/>
+                  <a:ea typeface="Inter" panose="02000503000000020004"/>
+                  <a:cs typeface="Inter" panose="02000503000000020004"/>
+                  <a:sym typeface="Inter" panose="02000503000000020004"/>
+                </a:rPr>
+                <a:t>1/5 × 100</a:t>
+              </a:r>
+              <a:r>
+                <a:rPr lang="en-US" altLang="en-GB" sz="1110" b="0">
+                  <a:solidFill>
+                    <a:srgbClr val="4F5D75"/>
+                  </a:solidFill>
+                  <a:latin typeface="Inter" panose="02000503000000020004"/>
+                  <a:ea typeface="Inter" panose="02000503000000020004"/>
+                  <a:cs typeface="Inter" panose="02000503000000020004"/>
+                  <a:sym typeface="Inter" panose="02000503000000020004"/>
+                </a:rPr>
+                <a:t> = -20</a:t>
               </a:r>
               <a:endParaRPr sz="1110" b="0">
                 <a:solidFill>
@@ -11799,9 +12039,33 @@
                   <a:cs typeface="Inter" panose="02000503000000020004"/>
                   <a:sym typeface="Inter" panose="02000503000000020004"/>
                 </a:rPr>
-                <a:t>Result: 20% Decrease</a:t>
+                <a:t>Result: </a:t>
               </a:r>
-              <a:endParaRPr sz="1110" b="1">
+              <a:r>
+                <a:rPr lang="en-US" altLang="en-GB" sz="1110" b="1">
+                  <a:solidFill>
+                    <a:srgbClr val="8B0000"/>
+                  </a:solidFill>
+                  <a:latin typeface="Inter" panose="02000503000000020004"/>
+                  <a:ea typeface="Inter" panose="02000503000000020004"/>
+                  <a:cs typeface="Inter" panose="02000503000000020004"/>
+                  <a:sym typeface="Inter" panose="02000503000000020004"/>
+                </a:rPr>
+                <a:t>-20% = </a:t>
+              </a:r>
+              <a:r>
+                <a:rPr lang="en-GB" sz="1110" b="1">
+                  <a:solidFill>
+                    <a:srgbClr val="8B0000"/>
+                  </a:solidFill>
+                  <a:latin typeface="Inter" panose="02000503000000020004"/>
+                  <a:ea typeface="Inter" panose="02000503000000020004"/>
+                  <a:cs typeface="Inter" panose="02000503000000020004"/>
+                  <a:sym typeface="Inter" panose="02000503000000020004"/>
+                </a:rPr>
+                <a:t>20% Decrease</a:t>
+              </a:r>
+              <a:endParaRPr lang="en-US" altLang="en-GB" sz="1110" b="1">
                 <a:solidFill>
                   <a:srgbClr val="8B0000"/>
                 </a:solidFill>
@@ -11877,8 +12141,8 @@
           </p:nvSpPr>
           <p:spPr>
             <a:xfrm>
-              <a:off x="228600" y="171450"/>
-              <a:ext cx="7772400" cy="285900"/>
+              <a:off x="228600" y="57150"/>
+              <a:ext cx="7772400" cy="400050"/>
             </a:xfrm>
             <a:prstGeom prst="rect">
               <a:avLst/>
@@ -11894,12 +12158,12 @@
             </a:bodyPr>
             <a:lstStyle/>
             <a:p>
-              <a:pPr marL="0" lvl="0" indent="0" algn="ctr" rtl="0">
-                <a:spcBef>
-                  <a:spcPts val="0"/>
-                </a:spcBef>
-                <a:spcAft>
-                  <a:spcPts val="0"/>
+              <a:pPr marL="0" lvl="0" indent="0" algn="ctr" rtl="0" eaLnBrk="1" fontAlgn="auto" latinLnBrk="0" hangingPunct="1">
+                <a:spcBef>
+                  <a:spcPts val="0"/>
+                </a:spcBef>
+                <a:spcAft>
+                  <a:spcPts val="500"/>
                 </a:spcAft>
                 <a:buNone/>
               </a:pPr>
@@ -11913,9 +12177,41 @@
                   <a:cs typeface="Inter SemiBold" panose="02000503000000020004"/>
                   <a:sym typeface="Inter SemiBold" panose="02000503000000020004"/>
                 </a:rPr>
-                <a:t>CRITICAL RULE: Always divide the absolute change by the ORIGINAL (starting) value to find the percentage.</a:t>
+                <a:t>CRITICAL RULE: Always divide the change by the ORIGINAL (starting) value to find the percentage.</a:t>
               </a:r>
-              <a:endParaRPr sz="1110" b="0">
+              <a:endParaRPr lang="en-GB" sz="1110" b="0">
+                <a:solidFill>
+                  <a:srgbClr val="F4F4F9"/>
+                </a:solidFill>
+                <a:latin typeface="Inter SemiBold" panose="02000503000000020004"/>
+                <a:ea typeface="Inter SemiBold" panose="02000503000000020004"/>
+                <a:cs typeface="Inter SemiBold" panose="02000503000000020004"/>
+                <a:sym typeface="Inter SemiBold" panose="02000503000000020004"/>
+              </a:endParaRPr>
+            </a:p>
+            <a:p>
+              <a:pPr marL="0" lvl="0" indent="0" algn="ctr" rtl="0" eaLnBrk="1" fontAlgn="auto" latinLnBrk="0" hangingPunct="1">
+                <a:spcBef>
+                  <a:spcPts val="0"/>
+                </a:spcBef>
+                <a:spcAft>
+                  <a:spcPts val="500"/>
+                </a:spcAft>
+                <a:buNone/>
+              </a:pPr>
+              <a:r>
+                <a:rPr lang="en-US" sz="1110" b="0">
+                  <a:solidFill>
+                    <a:srgbClr val="F4F4F9"/>
+                  </a:solidFill>
+                  <a:latin typeface="Inter SemiBold" panose="02000503000000020004"/>
+                  <a:ea typeface="Inter SemiBold" panose="02000503000000020004"/>
+                  <a:cs typeface="Inter SemiBold" panose="02000503000000020004"/>
+                  <a:sym typeface="Inter SemiBold" panose="02000503000000020004"/>
+                </a:rPr>
+                <a:t>Positive / Negative change indicates increase / decrease respectively.</a:t>
+              </a:r>
+              <a:endParaRPr lang="en-US" sz="1110" b="0">
                 <a:solidFill>
                   <a:srgbClr val="F4F4F9"/>
                 </a:solidFill>
@@ -12449,7 +12745,7 @@
         <p:grpSpPr>
           <a:xfrm>
             <a:off x="457200" y="1143000"/>
-            <a:ext cx="4000500" cy="1905000"/>
+            <a:ext cx="4000500" cy="2598420"/>
             <a:chOff x="0" y="0"/>
             <a:chExt cx="4000500" cy="1905000"/>
           </a:xfrm>
@@ -12688,20 +12984,20 @@
                 <a:buNone/>
               </a:pPr>
               <a:r>
-                <a:rPr lang="en-GB" sz="1100" b="0">
-                  <a:solidFill>
-                    <a:srgbClr val="E6F2FF"/>
+                <a:rPr lang="en-US" altLang="en-US" sz="1100" b="0">
+                  <a:solidFill>
+                    <a:schemeClr val="accent1"/>
                   </a:solidFill>
                   <a:latin typeface="Fira Code Medium" panose="020B0809050000020004"/>
                   <a:ea typeface="Fira Code Medium" panose="020B0809050000020004"/>
                   <a:cs typeface="Fira Code Medium" panose="020B0809050000020004"/>
                   <a:sym typeface="Fira Code Medium" panose="020B0809050000020004"/>
                 </a:rPr>
-                <a:t>X = 15</a:t>
+                <a:t>Set X = 15</a:t>
               </a:r>
-              <a:endParaRPr sz="1100" b="0">
+              <a:endParaRPr lang="en-US" altLang="en-US" sz="1100" b="0">
                 <a:solidFill>
-                  <a:srgbClr val="E6F2FF"/>
+                  <a:schemeClr val="accent1"/>
                 </a:solidFill>
                 <a:latin typeface="Fira Code Medium" panose="020B0809050000020004"/>
                 <a:ea typeface="Fira Code Medium" panose="020B0809050000020004"/>
@@ -12712,7 +13008,7 @@
             <a:p>
               <a:pPr marL="0" lvl="0" indent="0" algn="l" rtl="0">
                 <a:spcBef>
-                  <a:spcPts val="375"/>
+                  <a:spcPts val="0"/>
                 </a:spcBef>
                 <a:spcAft>
                   <a:spcPts val="0"/>
@@ -12720,20 +13016,20 @@
                 <a:buNone/>
               </a:pPr>
               <a:r>
-                <a:rPr lang="en-GB" sz="1100" b="0">
-                  <a:solidFill>
-                    <a:srgbClr val="E6F2FF"/>
+                <a:rPr lang="en-US" altLang="en-US" sz="1100" b="0">
+                  <a:solidFill>
+                    <a:schemeClr val="accent1"/>
                   </a:solidFill>
                   <a:latin typeface="Fira Code Medium" panose="020B0809050000020004"/>
                   <a:ea typeface="Fira Code Medium" panose="020B0809050000020004"/>
                   <a:cs typeface="Fira Code Medium" panose="020B0809050000020004"/>
                   <a:sym typeface="Fira Code Medium" panose="020B0809050000020004"/>
                 </a:rPr>
-                <a:t>Y = 25</a:t>
+                <a:t>Set Y = 25</a:t>
               </a:r>
-              <a:endParaRPr sz="1100" b="0">
+              <a:endParaRPr lang="en-US" altLang="en-US" sz="1100" b="0">
                 <a:solidFill>
-                  <a:srgbClr val="E6F2FF"/>
+                  <a:schemeClr val="accent1"/>
                 </a:solidFill>
                 <a:latin typeface="Fira Code Medium" panose="020B0809050000020004"/>
                 <a:ea typeface="Fira Code Medium" panose="020B0809050000020004"/>
@@ -12744,7 +13040,7 @@
             <a:p>
               <a:pPr marL="0" lvl="0" indent="0" algn="l" rtl="0">
                 <a:spcBef>
-                  <a:spcPts val="375"/>
+                  <a:spcPts val="0"/>
                 </a:spcBef>
                 <a:spcAft>
                   <a:spcPts val="0"/>
@@ -12752,20 +13048,20 @@
                 <a:buNone/>
               </a:pPr>
               <a:r>
-                <a:rPr lang="en-GB" sz="1100" b="0">
-                  <a:solidFill>
-                    <a:srgbClr val="E6F2FF"/>
+                <a:rPr lang="en-US" altLang="en-US" sz="1100" b="0">
+                  <a:solidFill>
+                    <a:schemeClr val="accent1"/>
                   </a:solidFill>
                   <a:latin typeface="Fira Code Medium" panose="020B0809050000020004"/>
                   <a:ea typeface="Fira Code Medium" panose="020B0809050000020004"/>
                   <a:cs typeface="Fira Code Medium" panose="020B0809050000020004"/>
                   <a:sym typeface="Fira Code Medium" panose="020B0809050000020004"/>
                 </a:rPr>
-                <a:t>If X &gt; 10 then</a:t>
+                <a:t>If X &gt; 10 Then</a:t>
               </a:r>
-              <a:endParaRPr sz="1100" b="0">
+              <a:endParaRPr lang="en-US" altLang="en-US" sz="1100" b="0">
                 <a:solidFill>
-                  <a:srgbClr val="E6F2FF"/>
+                  <a:schemeClr val="accent1"/>
                 </a:solidFill>
                 <a:latin typeface="Fira Code Medium" panose="020B0809050000020004"/>
                 <a:ea typeface="Fira Code Medium" panose="020B0809050000020004"/>
@@ -12776,7 +13072,7 @@
             <a:p>
               <a:pPr marL="0" lvl="0" indent="0" algn="l" rtl="0">
                 <a:spcBef>
-                  <a:spcPts val="375"/>
+                  <a:spcPts val="0"/>
                 </a:spcBef>
                 <a:spcAft>
                   <a:spcPts val="0"/>
@@ -12784,20 +13080,44 @@
                 <a:buNone/>
               </a:pPr>
               <a:r>
-                <a:rPr lang="en-GB" sz="1100" b="0">
-                  <a:solidFill>
-                    <a:srgbClr val="E6F2FF"/>
+                <a:rPr lang="en-US" altLang="en-US" sz="1100" b="0">
+                  <a:solidFill>
+                    <a:schemeClr val="accent1"/>
                   </a:solidFill>
                   <a:latin typeface="Fira Code Medium" panose="020B0809050000020004"/>
                   <a:ea typeface="Fira Code Medium" panose="020B0809050000020004"/>
                   <a:cs typeface="Fira Code Medium" panose="020B0809050000020004"/>
                   <a:sym typeface="Fira Code Medium" panose="020B0809050000020004"/>
                 </a:rPr>
-                <a:t>  X = 20</a:t>
+                <a:t>  X = X + 5  </a:t>
               </a:r>
-              <a:endParaRPr sz="1100" b="0">
+              <a:r>
+                <a:rPr lang="en-US" altLang="en-US" sz="1100" b="0">
+                  <a:solidFill>
+                    <a:srgbClr val="92D050"/>
+                  </a:solidFill>
+                  <a:latin typeface="Fira Code Medium" panose="020B0809050000020004"/>
+                  <a:ea typeface="Fira Code Medium" panose="020B0809050000020004"/>
+                  <a:cs typeface="Fira Code Medium" panose="020B0809050000020004"/>
+                  <a:sym typeface="Fira Code Medium" panose="020B0809050000020004"/>
+                </a:rPr>
+                <a:t>// X = 15 + 5 = 20</a:t>
+              </a:r>
+              <a:r>
+                <a:rPr lang="en-US" altLang="en-US" sz="1100" b="0">
+                  <a:solidFill>
+                    <a:schemeClr val="accent1"/>
+                  </a:solidFill>
+                  <a:latin typeface="Fira Code Medium" panose="020B0809050000020004"/>
+                  <a:ea typeface="Fira Code Medium" panose="020B0809050000020004"/>
+                  <a:cs typeface="Fira Code Medium" panose="020B0809050000020004"/>
+                  <a:sym typeface="Fira Code Medium" panose="020B0809050000020004"/>
+                </a:rPr>
+                <a:t> </a:t>
+              </a:r>
+              <a:endParaRPr lang="en-US" altLang="en-US" sz="1100" b="0">
                 <a:solidFill>
-                  <a:srgbClr val="E6F2FF"/>
+                  <a:srgbClr val="92D050"/>
                 </a:solidFill>
                 <a:latin typeface="Fira Code Medium" panose="020B0809050000020004"/>
                 <a:ea typeface="Fira Code Medium" panose="020B0809050000020004"/>
@@ -12808,28 +13128,200 @@
             <a:p>
               <a:pPr marL="0" lvl="0" indent="0" algn="l" rtl="0">
                 <a:spcBef>
-                  <a:spcPts val="375"/>
-                </a:spcBef>
-                <a:spcAft>
-                  <a:spcPts val="375"/>
+                  <a:spcPts val="0"/>
+                </a:spcBef>
+                <a:spcAft>
+                  <a:spcPts val="0"/>
                 </a:spcAft>
                 <a:buNone/>
               </a:pPr>
               <a:r>
-                <a:rPr lang="en-GB" sz="1100" b="0">
-                  <a:solidFill>
-                    <a:srgbClr val="E6F2FF"/>
+                <a:rPr lang="en-US" altLang="en-US" sz="1100" b="0">
+                  <a:solidFill>
+                    <a:schemeClr val="accent1"/>
                   </a:solidFill>
                   <a:latin typeface="Fira Code Medium" panose="020B0809050000020004"/>
                   <a:ea typeface="Fira Code Medium" panose="020B0809050000020004"/>
                   <a:cs typeface="Fira Code Medium" panose="020B0809050000020004"/>
                   <a:sym typeface="Fira Code Medium" panose="020B0809050000020004"/>
                 </a:rPr>
-                <a:t>Print Y - X</a:t>
+                <a:t>End If</a:t>
               </a:r>
-              <a:endParaRPr sz="1100" b="0">
+              <a:endParaRPr lang="en-US" altLang="en-US" sz="1100" b="0">
                 <a:solidFill>
-                  <a:srgbClr val="E6F2FF"/>
+                  <a:schemeClr val="accent1"/>
+                </a:solidFill>
+                <a:latin typeface="Fira Code Medium" panose="020B0809050000020004"/>
+                <a:ea typeface="Fira Code Medium" panose="020B0809050000020004"/>
+                <a:cs typeface="Fira Code Medium" panose="020B0809050000020004"/>
+                <a:sym typeface="Fira Code Medium" panose="020B0809050000020004"/>
+              </a:endParaRPr>
+            </a:p>
+            <a:p>
+              <a:pPr marL="0" lvl="0" indent="0" algn="l" rtl="0">
+                <a:spcBef>
+                  <a:spcPts val="0"/>
+                </a:spcBef>
+                <a:spcAft>
+                  <a:spcPts val="0"/>
+                </a:spcAft>
+                <a:buNone/>
+              </a:pPr>
+              <a:r>
+                <a:rPr lang="en-US" altLang="en-US" sz="1100" b="0">
+                  <a:solidFill>
+                    <a:schemeClr val="accent1"/>
+                  </a:solidFill>
+                  <a:latin typeface="Fira Code Medium" panose="020B0809050000020004"/>
+                  <a:ea typeface="Fira Code Medium" panose="020B0809050000020004"/>
+                  <a:cs typeface="Fira Code Medium" panose="020B0809050000020004"/>
+                  <a:sym typeface="Fira Code Medium" panose="020B0809050000020004"/>
+                </a:rPr>
+                <a:t>If Y &gt; X Then</a:t>
+              </a:r>
+              <a:endParaRPr lang="en-US" altLang="en-US" sz="1100" b="0">
+                <a:solidFill>
+                  <a:schemeClr val="accent1"/>
+                </a:solidFill>
+                <a:latin typeface="Fira Code Medium" panose="020B0809050000020004"/>
+                <a:ea typeface="Fira Code Medium" panose="020B0809050000020004"/>
+                <a:cs typeface="Fira Code Medium" panose="020B0809050000020004"/>
+                <a:sym typeface="Fira Code Medium" panose="020B0809050000020004"/>
+              </a:endParaRPr>
+            </a:p>
+            <a:p>
+              <a:pPr marL="0" lvl="0" indent="0" algn="l" rtl="0">
+                <a:spcBef>
+                  <a:spcPts val="0"/>
+                </a:spcBef>
+                <a:spcAft>
+                  <a:spcPts val="0"/>
+                </a:spcAft>
+                <a:buNone/>
+              </a:pPr>
+              <a:r>
+                <a:rPr lang="en-US" altLang="en-US" sz="1100" b="0">
+                  <a:solidFill>
+                    <a:schemeClr val="accent1"/>
+                  </a:solidFill>
+                  <a:latin typeface="Fira Code Medium" panose="020B0809050000020004"/>
+                  <a:ea typeface="Fira Code Medium" panose="020B0809050000020004"/>
+                  <a:cs typeface="Fira Code Medium" panose="020B0809050000020004"/>
+                  <a:sym typeface="Fira Code Medium" panose="020B0809050000020004"/>
+                </a:rPr>
+                <a:t>  Print Y - X </a:t>
+              </a:r>
+              <a:r>
+                <a:rPr lang="en-US" altLang="en-US" sz="1100" b="0">
+                  <a:solidFill>
+                    <a:srgbClr val="92D050"/>
+                  </a:solidFill>
+                  <a:latin typeface="Fira Code Medium" panose="020B0809050000020004"/>
+                  <a:ea typeface="Fira Code Medium" panose="020B0809050000020004"/>
+                  <a:cs typeface="Fira Code Medium" panose="020B0809050000020004"/>
+                  <a:sym typeface="Fira Code Medium" panose="020B0809050000020004"/>
+                </a:rPr>
+                <a:t> // 25 - 20 = 5</a:t>
+              </a:r>
+              <a:endParaRPr lang="en-US" altLang="en-US" sz="1100" b="0">
+                <a:solidFill>
+                  <a:schemeClr val="accent1"/>
+                </a:solidFill>
+                <a:latin typeface="Fira Code Medium" panose="020B0809050000020004"/>
+                <a:ea typeface="Fira Code Medium" panose="020B0809050000020004"/>
+                <a:cs typeface="Fira Code Medium" panose="020B0809050000020004"/>
+                <a:sym typeface="Fira Code Medium" panose="020B0809050000020004"/>
+              </a:endParaRPr>
+            </a:p>
+            <a:p>
+              <a:pPr marL="0" lvl="0" indent="0" algn="l" rtl="0">
+                <a:spcBef>
+                  <a:spcPts val="0"/>
+                </a:spcBef>
+                <a:spcAft>
+                  <a:spcPts val="0"/>
+                </a:spcAft>
+                <a:buNone/>
+              </a:pPr>
+              <a:r>
+                <a:rPr lang="en-US" altLang="en-US" sz="1100" b="0">
+                  <a:solidFill>
+                    <a:srgbClr val="FF0000"/>
+                  </a:solidFill>
+                  <a:latin typeface="Fira Code Medium" panose="020B0809050000020004"/>
+                  <a:ea typeface="Fira Code Medium" panose="020B0809050000020004"/>
+                  <a:cs typeface="Fira Code Medium" panose="020B0809050000020004"/>
+                  <a:sym typeface="Fira Code Medium" panose="020B0809050000020004"/>
+                </a:rPr>
+                <a:t>Else</a:t>
+              </a:r>
+              <a:endParaRPr lang="en-US" altLang="en-US" sz="1100" b="0">
+                <a:solidFill>
+                  <a:srgbClr val="FF0000"/>
+                </a:solidFill>
+                <a:latin typeface="Fira Code Medium" panose="020B0809050000020004"/>
+                <a:ea typeface="Fira Code Medium" panose="020B0809050000020004"/>
+                <a:cs typeface="Fira Code Medium" panose="020B0809050000020004"/>
+                <a:sym typeface="Fira Code Medium" panose="020B0809050000020004"/>
+              </a:endParaRPr>
+            </a:p>
+            <a:p>
+              <a:pPr marL="0" lvl="0" indent="0" algn="l" rtl="0">
+                <a:spcBef>
+                  <a:spcPts val="0"/>
+                </a:spcBef>
+                <a:spcAft>
+                  <a:spcPts val="0"/>
+                </a:spcAft>
+                <a:buNone/>
+              </a:pPr>
+              <a:r>
+                <a:rPr lang="en-US" altLang="en-US" sz="1100" b="0">
+                  <a:solidFill>
+                    <a:srgbClr val="FF0000"/>
+                  </a:solidFill>
+                  <a:latin typeface="Fira Code Medium" panose="020B0809050000020004"/>
+                  <a:ea typeface="Fira Code Medium" panose="020B0809050000020004"/>
+                  <a:cs typeface="Fira Code Medium" panose="020B0809050000020004"/>
+                  <a:sym typeface="Fira Code Medium" panose="020B0809050000020004"/>
+                </a:rPr>
+                <a:t>  Print X - Y</a:t>
+              </a:r>
+              <a:endParaRPr lang="en-US" altLang="en-US" sz="1100" b="0">
+                <a:solidFill>
+                  <a:srgbClr val="FF0000"/>
+                </a:solidFill>
+                <a:latin typeface="Fira Code Medium" panose="020B0809050000020004"/>
+                <a:ea typeface="Fira Code Medium" panose="020B0809050000020004"/>
+                <a:cs typeface="Fira Code Medium" panose="020B0809050000020004"/>
+                <a:sym typeface="Fira Code Medium" panose="020B0809050000020004"/>
+              </a:endParaRPr>
+            </a:p>
+            <a:p>
+              <a:pPr marL="0" lvl="0" indent="0" algn="l" rtl="0">
+                <a:spcBef>
+                  <a:spcPts val="0"/>
+                </a:spcBef>
+                <a:spcAft>
+                  <a:spcPts val="0"/>
+                </a:spcAft>
+                <a:buNone/>
+              </a:pPr>
+              <a:r>
+                <a:rPr lang="en-US" altLang="en-US" sz="1100" b="0">
+                  <a:solidFill>
+                    <a:srgbClr val="FF0000"/>
+                  </a:solidFill>
+                  <a:latin typeface="Fira Code Medium" panose="020B0809050000020004"/>
+                  <a:ea typeface="Fira Code Medium" panose="020B0809050000020004"/>
+                  <a:cs typeface="Fira Code Medium" panose="020B0809050000020004"/>
+                  <a:sym typeface="Fira Code Medium" panose="020B0809050000020004"/>
+                </a:rPr>
+                <a:t>End If</a:t>
+              </a:r>
+              <a:endParaRPr lang="en-US" altLang="en-US" sz="1100" b="0">
+                <a:solidFill>
+                  <a:srgbClr val="FF0000"/>
                 </a:solidFill>
                 <a:latin typeface="Fira Code Medium" panose="020B0809050000020004"/>
                 <a:ea typeface="Fira Code Medium" panose="020B0809050000020004"/>
@@ -12848,7 +13340,7 @@
         </p:nvGrpSpPr>
         <p:grpSpPr>
           <a:xfrm>
-            <a:off x="457200" y="3238500"/>
+            <a:off x="457200" y="3886200"/>
             <a:ext cx="4000500" cy="762000"/>
             <a:chOff x="0" y="0"/>
             <a:chExt cx="4000500" cy="762000"/>
@@ -13323,7 +13815,7 @@
                 </a:rPr>
                 <a:t>TRACE RESULTS</a:t>
               </a:r>
-              <a:endParaRPr sz="900" b="1">
+              <a:endParaRPr lang="en-US" altLang="en-GB" sz="900" b="1">
                 <a:solidFill>
                   <a:srgbClr val="8B0000"/>
                 </a:solidFill>
@@ -14112,10 +14604,10 @@
         </p:nvGrpSpPr>
         <p:grpSpPr>
           <a:xfrm>
-            <a:off x="457200" y="1143000"/>
-            <a:ext cx="8229600" cy="2476500"/>
-            <a:chOff x="0" y="0"/>
-            <a:chExt cx="8229600" cy="2476500"/>
+            <a:off x="456565" y="1143000"/>
+            <a:ext cx="8230235" cy="2476500"/>
+            <a:chOff x="-635" y="0"/>
+            <a:chExt cx="8230235" cy="2476500"/>
           </a:xfrm>
         </p:grpSpPr>
         <p:grpSp>
@@ -14126,10 +14618,10 @@
           </p:nvGrpSpPr>
           <p:grpSpPr>
             <a:xfrm>
-              <a:off x="0" y="0"/>
-              <a:ext cx="2590800" cy="2476500"/>
-              <a:chOff x="0" y="0"/>
-              <a:chExt cx="2590800" cy="2476500"/>
+              <a:off x="-635" y="0"/>
+              <a:ext cx="2591435" cy="2476500"/>
+              <a:chOff x="-635" y="0"/>
+              <a:chExt cx="2591435" cy="2476500"/>
             </a:xfrm>
           </p:grpSpPr>
           <p:sp>
@@ -14278,8 +14770,8 @@
             </p:nvSpPr>
             <p:spPr>
               <a:xfrm>
-                <a:off x="152400" y="571500"/>
-                <a:ext cx="2286000" cy="1714500"/>
+                <a:off x="-635" y="571500"/>
+                <a:ext cx="2591435" cy="1714500"/>
               </a:xfrm>
               <a:prstGeom prst="rect">
                 <a:avLst/>
@@ -14340,6 +14832,26 @@
                   </a:rPr>
                   <a:t> to decimal:</a:t>
                 </a:r>
+                <a:endParaRPr lang="en-GB" sz="1200" b="0">
+                  <a:solidFill>
+                    <a:srgbClr val="4F5D75"/>
+                  </a:solidFill>
+                  <a:latin typeface="Inter" panose="02000503000000020004"/>
+                  <a:ea typeface="Inter" panose="02000503000000020004"/>
+                  <a:cs typeface="Inter" panose="02000503000000020004"/>
+                  <a:sym typeface="Inter" panose="02000503000000020004"/>
+                </a:endParaRPr>
+              </a:p>
+              <a:p>
+                <a:pPr marL="0" lvl="0" indent="0" algn="l" rtl="0">
+                  <a:spcBef>
+                    <a:spcPts val="0"/>
+                  </a:spcBef>
+                  <a:spcAft>
+                    <a:spcPts val="0"/>
+                  </a:spcAft>
+                  <a:buNone/>
+                </a:pPr>
                 <a:endParaRPr sz="1200" b="0">
                   <a:solidFill>
                     <a:srgbClr val="4F5D75"/>
@@ -14361,6 +14873,30 @@
                   <a:buNone/>
                 </a:pPr>
                 <a:r>
+                  <a:rPr lang="en-GB" sz="1200">
+                    <a:solidFill>
+                      <a:srgbClr val="4F5D75"/>
+                    </a:solidFill>
+                    <a:latin typeface="Inter" panose="02000503000000020004"/>
+                    <a:ea typeface="Inter" panose="02000503000000020004"/>
+                    <a:cs typeface="Inter" panose="02000503000000020004"/>
+                    <a:sym typeface="Inter" panose="02000503000000020004"/>
+                  </a:rPr>
+                  <a:t>(1 * 2⁰) + (1 * 2¹) + (0 * 2²) +</a:t>
+                </a:r>
+                <a:r>
+                  <a:rPr lang="en-US" altLang="en-GB" sz="1200">
+                    <a:solidFill>
+                      <a:srgbClr val="4F5D75"/>
+                    </a:solidFill>
+                    <a:latin typeface="Inter" panose="02000503000000020004"/>
+                    <a:ea typeface="Inter" panose="02000503000000020004"/>
+                    <a:cs typeface="Inter" panose="02000503000000020004"/>
+                    <a:sym typeface="Inter" panose="02000503000000020004"/>
+                  </a:rPr>
+                  <a:t> </a:t>
+                </a:r>
+                <a:r>
                   <a:rPr lang="en-GB" sz="1200" b="0">
                     <a:solidFill>
                       <a:srgbClr val="4F5D75"/>
@@ -14370,7 +14906,7 @@
                     <a:cs typeface="Inter" panose="02000503000000020004"/>
                     <a:sym typeface="Inter" panose="02000503000000020004"/>
                   </a:rPr>
-                  <a:t>(1 * 2³) + (0 * 2²) + (1 * 2¹) + (1 * 2⁰)</a:t>
+                  <a:t>(1 * 2³)</a:t>
                 </a:r>
                 <a:endParaRPr sz="1200" b="0">
                   <a:solidFill>
@@ -14402,7 +14938,19 @@
                     <a:cs typeface="Inter" panose="02000503000000020004"/>
                     <a:sym typeface="Inter" panose="02000503000000020004"/>
                   </a:rPr>
-                  <a:t>= 8 + 0 + 2 + 1</a:t>
+                  <a:t>=1</a:t>
+                </a:r>
+                <a:r>
+                  <a:rPr lang="en-US" altLang="en-GB" sz="1200" b="0">
+                    <a:solidFill>
+                      <a:srgbClr val="4F5D75"/>
+                    </a:solidFill>
+                    <a:latin typeface="Inter" panose="02000503000000020004"/>
+                    <a:ea typeface="Inter" panose="02000503000000020004"/>
+                    <a:cs typeface="Inter" panose="02000503000000020004"/>
+                    <a:sym typeface="Inter" panose="02000503000000020004"/>
+                  </a:rPr>
+                  <a:t> + 2 + 0 + 8</a:t>
                 </a:r>
                 <a:endParaRPr sz="1200" b="0">
                   <a:solidFill>
@@ -16881,8 +17429,8 @@
           </p:nvSpPr>
           <p:spPr>
             <a:xfrm>
-              <a:off x="152400" y="533400"/>
-              <a:ext cx="3695700" cy="2000100"/>
+              <a:off x="152400" y="502285"/>
+              <a:ext cx="3695700" cy="2088515"/>
             </a:xfrm>
             <a:prstGeom prst="rect">
               <a:avLst/>
@@ -17047,7 +17595,7 @@
                 </a:rPr>
                 <a:t>Calculation:</a:t>
               </a:r>
-              <a:endParaRPr sz="1200" b="0">
+              <a:endParaRPr lang="en-GB" sz="1200" b="0">
                 <a:solidFill>
                   <a:srgbClr val="0A192F"/>
                 </a:solidFill>
@@ -17058,6 +17606,39 @@
               </a:endParaRPr>
             </a:p>
             <a:p>
+              <a:pPr marL="0" lvl="0" algn="l" rtl="0">
+                <a:spcBef>
+                  <a:spcPts val="800"/>
+                </a:spcBef>
+                <a:spcAft>
+                  <a:spcPts val="0"/>
+                </a:spcAft>
+                <a:buSzTx/>
+                <a:buNone/>
+              </a:pPr>
+              <a:r>
+                <a:rPr lang="en-US" altLang="en-GB" sz="1200">
+                  <a:solidFill>
+                    <a:srgbClr val="4F5D75"/>
+                  </a:solidFill>
+                  <a:latin typeface="Inter" panose="02000503000000020004"/>
+                  <a:ea typeface="Inter" panose="02000503000000020004"/>
+                  <a:cs typeface="Inter" panose="02000503000000020004"/>
+                  <a:sym typeface="Inter SemiBold" panose="02000503000000020004"/>
+                </a:rPr>
+                <a:t>Let Total Workspace be x.</a:t>
+              </a:r>
+              <a:endParaRPr lang="en-US" altLang="en-GB" sz="1200" b="0">
+                <a:solidFill>
+                  <a:srgbClr val="4F5D75"/>
+                </a:solidFill>
+                <a:latin typeface="Inter" panose="02000503000000020004"/>
+                <a:ea typeface="Inter" panose="02000503000000020004"/>
+                <a:cs typeface="Inter" panose="02000503000000020004"/>
+                <a:sym typeface="Inter SemiBold" panose="02000503000000020004"/>
+              </a:endParaRPr>
+            </a:p>
+            <a:p>
               <a:pPr marL="0" lvl="0" indent="0" algn="l" rtl="0">
                 <a:spcBef>
                   <a:spcPts val="800"/>
@@ -17077,10 +17658,10 @@
                   <a:cs typeface="Inter" panose="02000503000000020004"/>
                   <a:sym typeface="Inter" panose="02000503000000020004"/>
                 </a:rPr>
-                <a:t>25% of Total</a:t>
+                <a:t>25% of </a:t>
               </a:r>
               <a:r>
-                <a:rPr lang="en-US" altLang="en-GB" sz="1200" b="0">
+                <a:rPr lang="en-US" sz="1200" b="0">
                   <a:solidFill>
                     <a:srgbClr val="4F5D75"/>
                   </a:solidFill>
@@ -17089,7 +17670,7 @@
                   <a:cs typeface="Inter" panose="02000503000000020004"/>
                   <a:sym typeface="Inter" panose="02000503000000020004"/>
                 </a:rPr>
-                <a:t> Workforce</a:t>
+                <a:t>x</a:t>
               </a:r>
               <a:r>
                 <a:rPr lang="en-GB" sz="1200" b="0">
@@ -17124,7 +17705,7 @@
                 <a:buNone/>
               </a:pPr>
               <a:r>
-                <a:rPr lang="en-GB" sz="1200" b="0">
+                <a:rPr lang="en-US" altLang="en-GB" sz="1200" b="0">
                   <a:solidFill>
                     <a:srgbClr val="4F5D75"/>
                   </a:solidFill>
@@ -17133,7 +17714,19 @@
                   <a:cs typeface="Inter" panose="02000503000000020004"/>
                   <a:sym typeface="Inter" panose="02000503000000020004"/>
                 </a:rPr>
-                <a:t>Total Workforce = 150 / 25</a:t>
+                <a:t>x </a:t>
+              </a:r>
+              <a:r>
+                <a:rPr lang="en-GB" sz="1200" b="0">
+                  <a:solidFill>
+                    <a:srgbClr val="4F5D75"/>
+                  </a:solidFill>
+                  <a:latin typeface="Inter" panose="02000503000000020004"/>
+                  <a:ea typeface="Inter" panose="02000503000000020004"/>
+                  <a:cs typeface="Inter" panose="02000503000000020004"/>
+                  <a:sym typeface="Inter" panose="02000503000000020004"/>
+                </a:rPr>
+                <a:t> = 150 / 25</a:t>
               </a:r>
               <a:r>
                 <a:rPr lang="en-US" altLang="en-GB" sz="1200" b="0">
@@ -17157,30 +17750,10 @@
                   <a:cs typeface="Inter" panose="02000503000000020004"/>
                   <a:sym typeface="Inter" panose="02000503000000020004"/>
                 </a:rPr>
-                <a:t>              </a:t>
+                <a:t>  </a:t>
               </a:r>
-              <a:endParaRPr lang="en-US" altLang="en-GB" sz="1200">
-                <a:solidFill>
-                  <a:srgbClr val="4F5D75"/>
-                </a:solidFill>
-                <a:latin typeface="Inter" panose="02000503000000020004"/>
-                <a:ea typeface="Inter" panose="02000503000000020004"/>
-                <a:cs typeface="Inter" panose="02000503000000020004"/>
-                <a:sym typeface="Inter" panose="02000503000000020004"/>
-              </a:endParaRPr>
-            </a:p>
-            <a:p>
-              <a:pPr marL="0" lvl="0" indent="0" algn="l" rtl="0">
-                <a:spcBef>
-                  <a:spcPts val="0"/>
-                </a:spcBef>
-                <a:spcAft>
-                  <a:spcPts val="1000"/>
-                </a:spcAft>
-                <a:buNone/>
-              </a:pPr>
               <a:r>
-                <a:rPr lang="en-US" altLang="en-GB" sz="1200">
+                <a:rPr lang="en-GB" sz="1200">
                   <a:solidFill>
                     <a:srgbClr val="4F5D75"/>
                   </a:solidFill>
@@ -17189,10 +17762,10 @@
                   <a:cs typeface="Inter" panose="02000503000000020004"/>
                   <a:sym typeface="Inter" panose="02000503000000020004"/>
                 </a:rPr>
-                <a:t>                                 </a:t>
+                <a:t>= (150 / 25) * 100 = </a:t>
               </a:r>
               <a:r>
-                <a:rPr lang="en-GB" sz="1200">
+                <a:rPr lang="en-GB" sz="1200" b="1">
                   <a:solidFill>
                     <a:srgbClr val="4F5D75"/>
                   </a:solidFill>
@@ -17201,7 +17774,7 @@
                   <a:cs typeface="Inter" panose="02000503000000020004"/>
                   <a:sym typeface="Inter" panose="02000503000000020004"/>
                 </a:rPr>
-                <a:t>= (150 / 25) * 100 = 600</a:t>
+                <a:t>600</a:t>
               </a:r>
               <a:endParaRPr lang="en-GB" sz="1200" b="0">
                 <a:solidFill>
@@ -17469,7 +18042,31 @@
                   <a:cs typeface="Inter" panose="02000503000000020004"/>
                   <a:sym typeface="Inter" panose="02000503000000020004"/>
                 </a:rPr>
-                <a:t>• Difference in units: 5</a:t>
+                <a:t>• Difference in </a:t>
+              </a:r>
+              <a:r>
+                <a:rPr lang="en-US" altLang="en-GB" sz="1200" b="0">
+                  <a:solidFill>
+                    <a:srgbClr val="4F5D75"/>
+                  </a:solidFill>
+                  <a:latin typeface="Inter" panose="02000503000000020004"/>
+                  <a:ea typeface="Inter" panose="02000503000000020004"/>
+                  <a:cs typeface="Inter" panose="02000503000000020004"/>
+                  <a:sym typeface="Inter" panose="02000503000000020004"/>
+                </a:rPr>
+                <a:t>Salary</a:t>
+              </a:r>
+              <a:r>
+                <a:rPr lang="en-GB" sz="1200" b="0">
+                  <a:solidFill>
+                    <a:srgbClr val="4F5D75"/>
+                  </a:solidFill>
+                  <a:latin typeface="Inter" panose="02000503000000020004"/>
+                  <a:ea typeface="Inter" panose="02000503000000020004"/>
+                  <a:cs typeface="Inter" panose="02000503000000020004"/>
+                  <a:sym typeface="Inter" panose="02000503000000020004"/>
+                </a:rPr>
+                <a:t>: 5</a:t>
               </a:r>
               <a:r>
                 <a:rPr lang="en-US" altLang="en-GB" sz="1200" b="0">
@@ -17761,9 +18358,21 @@
                   <a:cs typeface="Inter" panose="02000503000000020004"/>
                   <a:sym typeface="Inter" panose="02000503000000020004"/>
                 </a:rPr>
-                <a:t>) = 3 * ₹20,000 = ₹60,000</a:t>
+                <a:t>) = 3 * ₹20,000 =</a:t>
               </a:r>
-              <a:endParaRPr sz="1200" b="0">
+              <a:r>
+                <a:rPr lang="en-GB" sz="1200" b="1">
+                  <a:solidFill>
+                    <a:srgbClr val="4F5D75"/>
+                  </a:solidFill>
+                  <a:latin typeface="Inter" panose="02000503000000020004"/>
+                  <a:ea typeface="Inter" panose="02000503000000020004"/>
+                  <a:cs typeface="Inter" panose="02000503000000020004"/>
+                  <a:sym typeface="Inter" panose="02000503000000020004"/>
+                </a:rPr>
+                <a:t> ₹60,000</a:t>
+              </a:r>
+              <a:endParaRPr sz="1200" b="1">
                 <a:solidFill>
                   <a:srgbClr val="4F5D75"/>
                 </a:solidFill>
@@ -20644,7 +21253,7 @@
           <p:spPr>
             <a:xfrm>
               <a:off x="152400" y="1819275"/>
-              <a:ext cx="3695700" cy="809700"/>
+              <a:ext cx="3695700" cy="866775"/>
             </a:xfrm>
             <a:prstGeom prst="rect">
               <a:avLst/>
@@ -20743,7 +21352,63 @@
                   <a:cs typeface="Inter" panose="02000503000000020004"/>
                   <a:sym typeface="Inter" panose="02000503000000020004"/>
                 </a:rPr>
-                <a:t>SP = 115% of CP → 4,600 / 1.15 = </a:t>
+                <a:t>SP = 115% of CP </a:t>
+              </a:r>
+              <a:r>
+                <a:rPr lang="en-US" altLang="en-GB" sz="1200" b="0">
+                  <a:solidFill>
+                    <a:srgbClr val="4F5D75"/>
+                  </a:solidFill>
+                  <a:latin typeface="Inter" panose="02000503000000020004"/>
+                  <a:ea typeface="Inter" panose="02000503000000020004"/>
+                  <a:cs typeface="Inter" panose="02000503000000020004"/>
+                  <a:sym typeface="Inter" panose="02000503000000020004"/>
+                </a:rPr>
+                <a:t> -&gt; 4,600 = 115/100 * CP </a:t>
+              </a:r>
+              <a:endParaRPr lang="en-GB" sz="1200" b="0">
+                <a:solidFill>
+                  <a:srgbClr val="4F5D75"/>
+                </a:solidFill>
+                <a:latin typeface="Inter" panose="02000503000000020004"/>
+                <a:ea typeface="Inter" panose="02000503000000020004"/>
+                <a:cs typeface="Inter" panose="02000503000000020004"/>
+                <a:sym typeface="Inter" panose="02000503000000020004"/>
+              </a:endParaRPr>
+            </a:p>
+            <a:p>
+              <a:pPr marL="0" lvl="0" indent="0" algn="l" rtl="0">
+                <a:spcBef>
+                  <a:spcPts val="0"/>
+                </a:spcBef>
+                <a:spcAft>
+                  <a:spcPts val="1000"/>
+                </a:spcAft>
+                <a:buNone/>
+              </a:pPr>
+              <a:r>
+                <a:rPr lang="en-US" altLang="en-GB" sz="1200" b="0">
+                  <a:solidFill>
+                    <a:srgbClr val="4F5D75"/>
+                  </a:solidFill>
+                  <a:latin typeface="Inter" panose="02000503000000020004"/>
+                  <a:ea typeface="Inter" panose="02000503000000020004"/>
+                  <a:cs typeface="Inter" panose="02000503000000020004"/>
+                  <a:sym typeface="Inter" panose="02000503000000020004"/>
+                </a:rPr>
+                <a:t>CP = </a:t>
+              </a:r>
+              <a:r>
+                <a:rPr lang="en-GB" sz="1200" b="0">
+                  <a:solidFill>
+                    <a:srgbClr val="4F5D75"/>
+                  </a:solidFill>
+                  <a:latin typeface="Inter" panose="02000503000000020004"/>
+                  <a:ea typeface="Inter" panose="02000503000000020004"/>
+                  <a:cs typeface="Inter" panose="02000503000000020004"/>
+                  <a:sym typeface="Inter" panose="02000503000000020004"/>
+                </a:rPr>
+                <a:t>4,600 / 1.15 = </a:t>
               </a:r>
               <a:r>
                 <a:rPr lang="en-GB" sz="1200" b="1">
@@ -26903,7 +27568,7 @@
         </p:nvGrpSpPr>
         <p:grpSpPr>
           <a:xfrm>
-            <a:off x="457200" y="1047750"/>
+            <a:off x="457200" y="1082040"/>
             <a:ext cx="4000500" cy="3571875"/>
             <a:chOff x="0" y="0"/>
             <a:chExt cx="4000500" cy="3571875"/>
@@ -27055,33 +27720,6 @@
             </a:p>
           </p:txBody>
         </p:sp>
-        <p:pic>
-          <p:nvPicPr>
-            <p:cNvPr id="304" name="Google Shape;304;p21"/>
-            <p:cNvPicPr preferRelativeResize="0"/>
-            <p:nvPr/>
-          </p:nvPicPr>
-          <p:blipFill rotWithShape="1">
-            <a:blip r:embed="rId1"/>
-            <a:srcRect/>
-            <a:stretch>
-              <a:fillRect/>
-            </a:stretch>
-          </p:blipFill>
-          <p:spPr>
-            <a:xfrm>
-              <a:off x="428625" y="523875"/>
-              <a:ext cx="3143400" cy="2357400"/>
-            </a:xfrm>
-            <a:prstGeom prst="rect">
-              <a:avLst/>
-            </a:prstGeom>
-            <a:noFill/>
-            <a:ln>
-              <a:noFill/>
-            </a:ln>
-          </p:spPr>
-        </p:pic>
         <p:sp>
           <p:nvSpPr>
             <p:cNvPr id="305" name="Google Shape;305;p21"/>
@@ -27814,6 +28452,332 @@
           </p:txBody>
         </p:sp>
       </p:grpSp>
+      <p:sp>
+        <p:nvSpPr>
+          <p:cNvPr id="3" name="Right Triangle 2"/>
+          <p:cNvSpPr/>
+          <p:nvPr/>
+        </p:nvSpPr>
+        <p:spPr>
+          <a:xfrm rot="5400000">
+            <a:off x="1790700" y="2090420"/>
+            <a:ext cx="1593850" cy="1352550"/>
+          </a:xfrm>
+          <a:prstGeom prst="rtTriangle">
+            <a:avLst/>
+          </a:prstGeom>
+          <a:solidFill>
+            <a:schemeClr val="bg1"/>
+          </a:solidFill>
+          <a:ln w="6350">
+            <a:solidFill>
+              <a:schemeClr val="tx1"/>
+            </a:solidFill>
+          </a:ln>
+        </p:spPr>
+        <p:style>
+          <a:lnRef idx="2">
+            <a:schemeClr val="accent1">
+              <a:lumMod val="75000"/>
+            </a:schemeClr>
+          </a:lnRef>
+          <a:fillRef idx="1">
+            <a:schemeClr val="accent1"/>
+          </a:fillRef>
+          <a:effectRef idx="0">
+            <a:srgbClr val="FFFFFF"/>
+          </a:effectRef>
+          <a:fontRef idx="minor">
+            <a:schemeClr val="lt1"/>
+          </a:fontRef>
+        </p:style>
+        <p:txBody>
+          <a:bodyPr rtlCol="0" anchor="ctr"/>
+          <a:p>
+            <a:pPr algn="ctr"/>
+            <a:endParaRPr lang="en-US"/>
+          </a:p>
+        </p:txBody>
+      </p:sp>
+      <p:sp>
+        <p:nvSpPr>
+          <p:cNvPr id="4" name="Text Box 3"/>
+          <p:cNvSpPr txBox="1"/>
+          <p:nvPr/>
+        </p:nvSpPr>
+        <p:spPr>
+          <a:xfrm>
+            <a:off x="3200400" y="1753870"/>
+            <a:ext cx="254000" cy="304800"/>
+          </a:xfrm>
+          <a:prstGeom prst="rect">
+            <a:avLst/>
+          </a:prstGeom>
+          <a:noFill/>
+        </p:spPr>
+        <p:txBody>
+          <a:bodyPr wrap="square" rtlCol="0">
+            <a:noAutofit/>
+          </a:bodyPr>
+          <a:p>
+            <a:pPr lvl="0" algn="l">
+              <a:buSzTx/>
+            </a:pPr>
+            <a:r>
+              <a:rPr lang="en-US" sz="1000">
+                <a:sym typeface="+mn-ea"/>
+              </a:rPr>
+              <a:t>B</a:t>
+            </a:r>
+            <a:endParaRPr lang="en-US" sz="1000">
+              <a:sym typeface="+mn-ea"/>
+            </a:endParaRPr>
+          </a:p>
+        </p:txBody>
+      </p:sp>
+      <p:sp>
+        <p:nvSpPr>
+          <p:cNvPr id="5" name="Text Box 4"/>
+          <p:cNvSpPr txBox="1"/>
+          <p:nvPr/>
+        </p:nvSpPr>
+        <p:spPr>
+          <a:xfrm>
+            <a:off x="1714500" y="3500120"/>
+            <a:ext cx="254000" cy="304800"/>
+          </a:xfrm>
+          <a:prstGeom prst="rect">
+            <a:avLst/>
+          </a:prstGeom>
+          <a:noFill/>
+        </p:spPr>
+        <p:txBody>
+          <a:bodyPr wrap="square" rtlCol="0">
+            <a:noAutofit/>
+          </a:bodyPr>
+          <a:p>
+            <a:pPr lvl="0" algn="l">
+              <a:buSzTx/>
+            </a:pPr>
+            <a:r>
+              <a:rPr lang="en-US" sz="1000">
+                <a:sym typeface="+mn-ea"/>
+              </a:rPr>
+              <a:t>O</a:t>
+            </a:r>
+            <a:endParaRPr lang="en-US" sz="1000">
+              <a:sym typeface="+mn-ea"/>
+            </a:endParaRPr>
+          </a:p>
+        </p:txBody>
+      </p:sp>
+      <p:sp>
+        <p:nvSpPr>
+          <p:cNvPr id="6" name="Text Box 5"/>
+          <p:cNvSpPr txBox="1"/>
+          <p:nvPr/>
+        </p:nvSpPr>
+        <p:spPr>
+          <a:xfrm>
+            <a:off x="1657350" y="1789430"/>
+            <a:ext cx="254000" cy="304800"/>
+          </a:xfrm>
+          <a:prstGeom prst="rect">
+            <a:avLst/>
+          </a:prstGeom>
+          <a:noFill/>
+        </p:spPr>
+        <p:txBody>
+          <a:bodyPr wrap="square" rtlCol="0">
+            <a:noAutofit/>
+          </a:bodyPr>
+          <a:p>
+            <a:r>
+              <a:rPr lang="en-US" sz="1000"/>
+              <a:t>A</a:t>
+            </a:r>
+            <a:endParaRPr lang="en-US" sz="1000"/>
+          </a:p>
+        </p:txBody>
+      </p:sp>
+      <p:sp>
+        <p:nvSpPr>
+          <p:cNvPr id="7" name="Text Box 6"/>
+          <p:cNvSpPr txBox="1"/>
+          <p:nvPr/>
+        </p:nvSpPr>
+        <p:spPr>
+          <a:xfrm>
+            <a:off x="2387600" y="1722120"/>
+            <a:ext cx="481965" cy="304800"/>
+          </a:xfrm>
+          <a:prstGeom prst="rect">
+            <a:avLst/>
+          </a:prstGeom>
+          <a:noFill/>
+        </p:spPr>
+        <p:txBody>
+          <a:bodyPr wrap="square" rtlCol="0">
+            <a:noAutofit/>
+          </a:bodyPr>
+          <a:p>
+            <a:pPr lvl="0" algn="l">
+              <a:buSzTx/>
+            </a:pPr>
+            <a:r>
+              <a:rPr lang="en-US" sz="1000">
+                <a:sym typeface="+mn-ea"/>
+              </a:rPr>
+              <a:t>6m</a:t>
+            </a:r>
+            <a:endParaRPr lang="en-US" sz="1000">
+              <a:sym typeface="+mn-ea"/>
+            </a:endParaRPr>
+          </a:p>
+        </p:txBody>
+      </p:sp>
+      <p:sp>
+        <p:nvSpPr>
+          <p:cNvPr id="8" name="Text Box 7"/>
+          <p:cNvSpPr txBox="1"/>
+          <p:nvPr/>
+        </p:nvSpPr>
+        <p:spPr>
+          <a:xfrm>
+            <a:off x="1562735" y="2491740"/>
+            <a:ext cx="481965" cy="304800"/>
+          </a:xfrm>
+          <a:prstGeom prst="rect">
+            <a:avLst/>
+          </a:prstGeom>
+          <a:noFill/>
+        </p:spPr>
+        <p:txBody>
+          <a:bodyPr wrap="square" rtlCol="0">
+            <a:noAutofit/>
+          </a:bodyPr>
+          <a:p>
+            <a:pPr lvl="0" algn="l">
+              <a:buSzTx/>
+            </a:pPr>
+            <a:r>
+              <a:rPr lang="en-US" sz="1000">
+                <a:sym typeface="+mn-ea"/>
+              </a:rPr>
+              <a:t>8m</a:t>
+            </a:r>
+            <a:endParaRPr lang="en-US" sz="1000">
+              <a:sym typeface="+mn-ea"/>
+            </a:endParaRPr>
+          </a:p>
+        </p:txBody>
+      </p:sp>
+      <p:sp>
+        <p:nvSpPr>
+          <p:cNvPr id="9" name="Text Box 8"/>
+          <p:cNvSpPr txBox="1"/>
+          <p:nvPr/>
+        </p:nvSpPr>
+        <p:spPr>
+          <a:xfrm>
+            <a:off x="2648585" y="2609850"/>
+            <a:ext cx="615315" cy="304800"/>
+          </a:xfrm>
+          <a:prstGeom prst="rect">
+            <a:avLst/>
+          </a:prstGeom>
+          <a:noFill/>
+        </p:spPr>
+        <p:txBody>
+          <a:bodyPr wrap="square" rtlCol="0">
+            <a:noAutofit/>
+          </a:bodyPr>
+          <a:p>
+            <a:pPr lvl="0" algn="l">
+              <a:buSzTx/>
+            </a:pPr>
+            <a:r>
+              <a:rPr lang="en-US" sz="1000">
+                <a:sym typeface="+mn-ea"/>
+              </a:rPr>
+              <a:t>10m</a:t>
+            </a:r>
+            <a:endParaRPr lang="en-US" sz="1000">
+              <a:sym typeface="+mn-ea"/>
+            </a:endParaRPr>
+          </a:p>
+        </p:txBody>
+      </p:sp>
+      <p:cxnSp>
+        <p:nvCxnSpPr>
+          <p:cNvPr id="10" name="Straight Connector 9"/>
+          <p:cNvCxnSpPr/>
+          <p:nvPr/>
+        </p:nvCxnSpPr>
+        <p:spPr>
+          <a:xfrm>
+            <a:off x="2070100" y="1974850"/>
+            <a:ext cx="0" cy="152400"/>
+          </a:xfrm>
+          <a:prstGeom prst="line">
+            <a:avLst/>
+          </a:prstGeom>
+          <a:ln w="6350">
+            <a:solidFill>
+              <a:schemeClr val="tx1"/>
+            </a:solidFill>
+          </a:ln>
+        </p:spPr>
+        <p:style>
+          <a:lnRef idx="2">
+            <a:schemeClr val="accent1"/>
+          </a:lnRef>
+          <a:fillRef idx="0">
+            <a:srgbClr val="FFFFFF"/>
+          </a:fillRef>
+          <a:effectRef idx="0">
+            <a:srgbClr val="FFFFFF"/>
+          </a:effectRef>
+          <a:fontRef idx="minor">
+            <a:schemeClr val="tx1"/>
+          </a:fontRef>
+        </p:style>
+      </p:cxnSp>
+      <p:cxnSp>
+        <p:nvCxnSpPr>
+          <p:cNvPr id="11" name="Straight Connector 10"/>
+          <p:cNvCxnSpPr/>
+          <p:nvPr/>
+        </p:nvCxnSpPr>
+        <p:spPr>
+          <a:xfrm>
+            <a:off x="1917700" y="2131695"/>
+            <a:ext cx="149225" cy="0"/>
+          </a:xfrm>
+          <a:prstGeom prst="line">
+            <a:avLst/>
+          </a:prstGeom>
+          <a:ln w="6350">
+            <a:solidFill>
+              <a:schemeClr val="tx1"/>
+            </a:solidFill>
+          </a:ln>
+        </p:spPr>
+        <p:style>
+          <a:lnRef idx="2">
+            <a:schemeClr val="accent1"/>
+          </a:lnRef>
+          <a:fillRef idx="0">
+            <a:srgbClr val="FFFFFF"/>
+          </a:fillRef>
+          <a:effectRef idx="0">
+            <a:srgbClr val="FFFFFF"/>
+          </a:effectRef>
+          <a:fontRef idx="minor">
+            <a:schemeClr val="tx1"/>
+          </a:fontRef>
+        </p:style>
+      </p:cxnSp>
     </p:spTree>
   </p:cSld>
   <p:clrMapOvr>
@@ -28534,10 +29498,10 @@
           </p:nvGrpSpPr>
           <p:grpSpPr>
             <a:xfrm>
-              <a:off x="2190750" y="571500"/>
-              <a:ext cx="1619100" cy="1214400"/>
-              <a:chOff x="0" y="0"/>
-              <a:chExt cx="1619100" cy="1214400"/>
+              <a:off x="2183932" y="883285"/>
+              <a:ext cx="1743393" cy="1364615"/>
+              <a:chOff x="-6818" y="311785"/>
+              <a:chExt cx="1743393" cy="1364615"/>
             </a:xfrm>
           </p:grpSpPr>
           <p:pic>
@@ -28555,7 +29519,7 @@
             </p:blipFill>
             <p:spPr>
               <a:xfrm>
-                <a:off x="0" y="0"/>
+                <a:off x="117475" y="345440"/>
                 <a:ext cx="1619100" cy="1214400"/>
               </a:xfrm>
               <a:prstGeom prst="rect">
@@ -28575,8 +29539,8 @@
             </p:nvSpPr>
             <p:spPr>
               <a:xfrm>
-                <a:off x="0" y="0"/>
-                <a:ext cx="1619100" cy="1214400"/>
+                <a:off x="-6818" y="311785"/>
+                <a:ext cx="1619250" cy="1364615"/>
               </a:xfrm>
               <a:prstGeom prst="roundRect">
                 <a:avLst>

</xml_diff>